<commit_message>
Última tentativa de atualizar
Não quero mais
</commit_message>
<xml_diff>
--- a/pitch Gladia Mandin.pptx
+++ b/pitch Gladia Mandin.pptx
@@ -18,11 +18,11 @@
   <p:notesSz cx="6858000" cy="9144000"/>
   <p:embeddedFontLst>
     <p:embeddedFont>
-      <p:font typeface="Roboto" charset="1" panose="02000000000000000000"/>
+      <p:font typeface="Arcade Gamer" charset="1" panose="00000000000000000000"/>
       <p:regular r:id="rId14"/>
     </p:embeddedFont>
     <p:embeddedFont>
-      <p:font typeface="Arcade Gamer" charset="1" panose="00000000000000000000"/>
+      <p:font typeface="Roboto" charset="1" panose="02000000000000000000"/>
       <p:regular r:id="rId15"/>
     </p:embeddedFont>
     <p:embeddedFont>
@@ -8534,140 +8534,7 @@
       </p:grpSp>
       <p:sp>
         <p:nvSpPr>
-          <p:cNvPr name="TextBox 18" id="18"/>
-          <p:cNvSpPr txBox="true"/>
-          <p:nvPr/>
-        </p:nvSpPr>
-        <p:spPr>
-          <a:xfrm rot="0">
-            <a:off x="13944637" y="6183157"/>
-            <a:ext cx="6978771" cy="677447"/>
-          </a:xfrm>
-          <a:prstGeom prst="rect">
-            <a:avLst/>
-          </a:prstGeom>
-        </p:spPr>
-        <p:txBody>
-          <a:bodyPr anchor="t" rtlCol="false" tIns="0" lIns="0" bIns="0" rIns="0">
-            <a:spAutoFit/>
-          </a:bodyPr>
-          <a:lstStyle/>
-          <a:p>
-            <a:pPr algn="just">
-              <a:lnSpc>
-                <a:spcPts val="2722"/>
-              </a:lnSpc>
-              <a:spcBef>
-                <a:spcPct val="0"/>
-              </a:spcBef>
-            </a:pPr>
-            <a:r>
-              <a:rPr lang="en-US" sz="1944">
-                <a:solidFill>
-                  <a:srgbClr val="FFFFFF"/>
-                </a:solidFill>
-                <a:latin typeface="Roboto"/>
-                <a:ea typeface="Roboto"/>
-                <a:cs typeface="Roboto"/>
-                <a:sym typeface="Roboto"/>
-              </a:rPr>
-              <a:t>Treine, Evolua e Conquiste Mandinhos para recuperar seu melhor amigo.</a:t>
-            </a:r>
-          </a:p>
-        </p:txBody>
-      </p:sp>
-      <p:sp>
-        <p:nvSpPr>
-          <p:cNvPr name="TextBox 19" id="19"/>
-          <p:cNvSpPr txBox="true"/>
-          <p:nvPr/>
-        </p:nvSpPr>
-        <p:spPr>
-          <a:xfrm rot="0">
-            <a:off x="12334799" y="41789"/>
-            <a:ext cx="6978771" cy="4073545"/>
-          </a:xfrm>
-          <a:prstGeom prst="rect">
-            <a:avLst/>
-          </a:prstGeom>
-        </p:spPr>
-        <p:txBody>
-          <a:bodyPr anchor="t" rtlCol="false" tIns="0" lIns="0" bIns="0" rIns="0">
-            <a:spAutoFit/>
-          </a:bodyPr>
-          <a:lstStyle/>
-          <a:p>
-            <a:pPr algn="just">
-              <a:lnSpc>
-                <a:spcPts val="2722"/>
-              </a:lnSpc>
-            </a:pPr>
-            <a:r>
-              <a:rPr lang="en-US" sz="1944">
-                <a:solidFill>
-                  <a:srgbClr val="FFFFFF"/>
-                </a:solidFill>
-                <a:latin typeface="Roboto"/>
-                <a:ea typeface="Roboto"/>
-                <a:cs typeface="Roboto"/>
-                <a:sym typeface="Roboto"/>
-              </a:rPr>
-              <a:t>Após o fim desse torneio, é anunciada uma atualização nas regras da competição, permitindo batalhas em duplas, no formato 2x2, tornando-o o primeiro torneio de Mandinhos™ a permitir esse tipo de batalha.</a:t>
-            </a:r>
-          </a:p>
-          <a:p>
-            <a:pPr algn="just">
-              <a:lnSpc>
-                <a:spcPts val="2722"/>
-              </a:lnSpc>
-            </a:pPr>
-            <a:r>
-              <a:rPr lang="en-US" sz="1944">
-                <a:solidFill>
-                  <a:srgbClr val="FFFFFF"/>
-                </a:solidFill>
-                <a:latin typeface="Roboto"/>
-                <a:ea typeface="Roboto"/>
-                <a:cs typeface="Roboto"/>
-                <a:sym typeface="Roboto"/>
-              </a:rPr>
-              <a:t>Também é anunciado que a mulher que derrotou você no torneio anterior participará desta nova competição, dando a você uma última chance de recuperar seu fiel companheiro.</a:t>
-            </a:r>
-          </a:p>
-          <a:p>
-            <a:pPr algn="just">
-              <a:lnSpc>
-                <a:spcPts val="2722"/>
-              </a:lnSpc>
-            </a:pPr>
-            <a:r>
-              <a:rPr lang="en-US" sz="1944">
-                <a:solidFill>
-                  <a:srgbClr val="FFFFFF"/>
-                </a:solidFill>
-                <a:latin typeface="Roboto"/>
-                <a:ea typeface="Roboto"/>
-                <a:cs typeface="Roboto"/>
-                <a:sym typeface="Roboto"/>
-              </a:rPr>
-              <a:t>Determinado a aproveitar essa oportunidade, você decide entrar no torneio ao lado de um novo Mandinho™, com dois objetivos em mente: recuperar seu melhor amigo e se vingar pela derrota que sofreu.</a:t>
-            </a:r>
-          </a:p>
-          <a:p>
-            <a:pPr algn="just">
-              <a:lnSpc>
-                <a:spcPts val="2722"/>
-              </a:lnSpc>
-              <a:spcBef>
-                <a:spcPct val="0"/>
-              </a:spcBef>
-            </a:pPr>
-          </a:p>
-        </p:txBody>
-      </p:sp>
-      <p:sp>
-        <p:nvSpPr>
-          <p:cNvPr name="Freeform 20" id="20"/>
+          <p:cNvPr name="Freeform 18" id="18"/>
           <p:cNvSpPr/>
           <p:nvPr/>
         </p:nvSpPr>
@@ -8713,7 +8580,7 @@
       </p:sp>
       <p:sp>
         <p:nvSpPr>
-          <p:cNvPr name="TextBox 21" id="21"/>
+          <p:cNvPr name="TextBox 19" id="19"/>
           <p:cNvSpPr txBox="true"/>
           <p:nvPr/>
         </p:nvSpPr>
@@ -8757,14 +8624,216 @@
       </p:sp>
       <p:sp>
         <p:nvSpPr>
-          <p:cNvPr name="TextBox 22" id="22"/>
+          <p:cNvPr name="Freeform 20" id="20"/>
+          <p:cNvSpPr/>
+          <p:nvPr/>
+        </p:nvSpPr>
+        <p:spPr>
+          <a:xfrm flipH="true" flipV="false" rot="0">
+            <a:off x="4671596" y="438644"/>
+            <a:ext cx="608122" cy="608122"/>
+          </a:xfrm>
+          <a:custGeom>
+            <a:avLst/>
+            <a:gdLst/>
+            <a:ahLst/>
+            <a:cxnLst/>
+            <a:rect r="r" b="b" t="t" l="l"/>
+            <a:pathLst>
+              <a:path h="608122" w="608122">
+                <a:moveTo>
+                  <a:pt x="608122" y="0"/>
+                </a:moveTo>
+                <a:lnTo>
+                  <a:pt x="0" y="0"/>
+                </a:lnTo>
+                <a:lnTo>
+                  <a:pt x="0" y="608122"/>
+                </a:lnTo>
+                <a:lnTo>
+                  <a:pt x="608122" y="608122"/>
+                </a:lnTo>
+                <a:lnTo>
+                  <a:pt x="608122" y="0"/>
+                </a:lnTo>
+                <a:close/>
+              </a:path>
+            </a:pathLst>
+          </a:custGeom>
+          <a:blipFill>
+            <a:blip r:embed="rId13">
+              <a:extLst>
+                <a:ext uri="{96DAC541-7B7A-43D3-8B79-37D633B846F1}">
+                  <asvg:svgBlip xmlns:asvg="http://schemas.microsoft.com/office/drawing/2016/SVG/main" r:embed="rId14"/>
+                </a:ext>
+              </a:extLst>
+            </a:blip>
+            <a:stretch>
+              <a:fillRect l="0" t="0" r="0" b="0"/>
+            </a:stretch>
+          </a:blipFill>
+        </p:spPr>
+      </p:sp>
+      <p:sp>
+        <p:nvSpPr>
+          <p:cNvPr name="Freeform 21" id="21"/>
+          <p:cNvSpPr/>
+          <p:nvPr/>
+        </p:nvSpPr>
+        <p:spPr>
+          <a:xfrm flipH="true" flipV="false" rot="0">
+            <a:off x="8394869" y="328008"/>
+            <a:ext cx="608122" cy="608122"/>
+          </a:xfrm>
+          <a:custGeom>
+            <a:avLst/>
+            <a:gdLst/>
+            <a:ahLst/>
+            <a:cxnLst/>
+            <a:rect r="r" b="b" t="t" l="l"/>
+            <a:pathLst>
+              <a:path h="608122" w="608122">
+                <a:moveTo>
+                  <a:pt x="608122" y="0"/>
+                </a:moveTo>
+                <a:lnTo>
+                  <a:pt x="0" y="0"/>
+                </a:lnTo>
+                <a:lnTo>
+                  <a:pt x="0" y="608122"/>
+                </a:lnTo>
+                <a:lnTo>
+                  <a:pt x="608122" y="608122"/>
+                </a:lnTo>
+                <a:lnTo>
+                  <a:pt x="608122" y="0"/>
+                </a:lnTo>
+                <a:close/>
+              </a:path>
+            </a:pathLst>
+          </a:custGeom>
+          <a:blipFill>
+            <a:blip r:embed="rId13">
+              <a:extLst>
+                <a:ext uri="{96DAC541-7B7A-43D3-8B79-37D633B846F1}">
+                  <asvg:svgBlip xmlns:asvg="http://schemas.microsoft.com/office/drawing/2016/SVG/main" r:embed="rId14"/>
+                </a:ext>
+              </a:extLst>
+            </a:blip>
+            <a:stretch>
+              <a:fillRect l="0" t="0" r="0" b="0"/>
+            </a:stretch>
+          </a:blipFill>
+        </p:spPr>
+      </p:sp>
+      <p:sp>
+        <p:nvSpPr>
+          <p:cNvPr name="Freeform 22" id="22"/>
+          <p:cNvSpPr/>
+          <p:nvPr/>
+        </p:nvSpPr>
+        <p:spPr>
+          <a:xfrm flipH="true" flipV="false" rot="0">
+            <a:off x="16126300" y="150840"/>
+            <a:ext cx="608122" cy="608122"/>
+          </a:xfrm>
+          <a:custGeom>
+            <a:avLst/>
+            <a:gdLst/>
+            <a:ahLst/>
+            <a:cxnLst/>
+            <a:rect r="r" b="b" t="t" l="l"/>
+            <a:pathLst>
+              <a:path h="608122" w="608122">
+                <a:moveTo>
+                  <a:pt x="608122" y="0"/>
+                </a:moveTo>
+                <a:lnTo>
+                  <a:pt x="0" y="0"/>
+                </a:lnTo>
+                <a:lnTo>
+                  <a:pt x="0" y="608122"/>
+                </a:lnTo>
+                <a:lnTo>
+                  <a:pt x="608122" y="608122"/>
+                </a:lnTo>
+                <a:lnTo>
+                  <a:pt x="608122" y="0"/>
+                </a:lnTo>
+                <a:close/>
+              </a:path>
+            </a:pathLst>
+          </a:custGeom>
+          <a:blipFill>
+            <a:blip r:embed="rId13">
+              <a:extLst>
+                <a:ext uri="{96DAC541-7B7A-43D3-8B79-37D633B846F1}">
+                  <asvg:svgBlip xmlns:asvg="http://schemas.microsoft.com/office/drawing/2016/SVG/main" r:embed="rId14"/>
+                </a:ext>
+              </a:extLst>
+            </a:blip>
+            <a:stretch>
+              <a:fillRect l="0" t="0" r="0" b="0"/>
+            </a:stretch>
+          </a:blipFill>
+        </p:spPr>
+      </p:sp>
+      <p:sp>
+        <p:nvSpPr>
+          <p:cNvPr name="Freeform 23" id="23"/>
+          <p:cNvSpPr/>
+          <p:nvPr/>
+        </p:nvSpPr>
+        <p:spPr>
+          <a:xfrm flipH="false" flipV="false" rot="0">
+            <a:off x="16166242" y="-425881"/>
+            <a:ext cx="3138073" cy="1765166"/>
+          </a:xfrm>
+          <a:custGeom>
+            <a:avLst/>
+            <a:gdLst/>
+            <a:ahLst/>
+            <a:cxnLst/>
+            <a:rect r="r" b="b" t="t" l="l"/>
+            <a:pathLst>
+              <a:path h="1765166" w="3138073">
+                <a:moveTo>
+                  <a:pt x="0" y="0"/>
+                </a:moveTo>
+                <a:lnTo>
+                  <a:pt x="3138073" y="0"/>
+                </a:lnTo>
+                <a:lnTo>
+                  <a:pt x="3138073" y="1765166"/>
+                </a:lnTo>
+                <a:lnTo>
+                  <a:pt x="0" y="1765166"/>
+                </a:lnTo>
+                <a:lnTo>
+                  <a:pt x="0" y="0"/>
+                </a:lnTo>
+                <a:close/>
+              </a:path>
+            </a:pathLst>
+          </a:custGeom>
+          <a:blipFill>
+            <a:blip r:embed="rId15"/>
+            <a:stretch>
+              <a:fillRect l="0" t="0" r="0" b="0"/>
+            </a:stretch>
+          </a:blipFill>
+        </p:spPr>
+      </p:sp>
+      <p:sp>
+        <p:nvSpPr>
+          <p:cNvPr name="TextBox 24" id="24"/>
           <p:cNvSpPr txBox="true"/>
           <p:nvPr/>
         </p:nvSpPr>
         <p:spPr>
           <a:xfrm rot="0">
-            <a:off x="-281877" y="-3374992"/>
-            <a:ext cx="6689457" cy="5859831"/>
+            <a:off x="4215445" y="3970982"/>
+            <a:ext cx="10116889" cy="2222748"/>
           </a:xfrm>
           <a:prstGeom prst="rect">
             <a:avLst/>
@@ -8778,11 +8847,11 @@
           <a:p>
             <a:pPr algn="just">
               <a:lnSpc>
-                <a:spcPts val="2609"/>
+                <a:spcPts val="2965"/>
               </a:lnSpc>
             </a:pPr>
             <a:r>
-              <a:rPr lang="en-US" sz="1864">
+              <a:rPr lang="en-US" sz="2118">
                 <a:solidFill>
                   <a:srgbClr val="FFFFFF"/>
                 </a:solidFill>
@@ -8791,17 +8860,27 @@
                 <a:cs typeface="Roboto"/>
                 <a:sym typeface="Roboto"/>
               </a:rPr>
-              <a:t>Você é um jovem treinador de Mandinhos™, talentoso por natureza. Mesmo com pouca experiência, venceu inúmeras competições ao lado de seu melhor amigo e companheiro, {mandinho}. Suas vitórias fizeram com que você se tornasse convencido e extremamente arrogante de que jamais poderia ser derrotado.</a:t>
+              <a:t>Ao perder seu melhor Mandinho para uma treinadora misteriosa em um campeonato de batalhas de Mandinhos, você cria o objetivo de recupera-lo vencendo-a no novo torneio que está por vir a qualquer custo.</a:t>
             </a:r>
           </a:p>
           <a:p>
             <a:pPr algn="just">
               <a:lnSpc>
-                <a:spcPts val="2609"/>
+                <a:spcPts val="2965"/>
               </a:lnSpc>
             </a:pPr>
+          </a:p>
+          <a:p>
+            <a:pPr algn="just">
+              <a:lnSpc>
+                <a:spcPts val="2965"/>
+              </a:lnSpc>
+              <a:spcBef>
+                <a:spcPct val="0"/>
+              </a:spcBef>
+            </a:pPr>
             <a:r>
-              <a:rPr lang="en-US" sz="1864">
+              <a:rPr lang="en-US" sz="2118">
                 <a:solidFill>
                   <a:srgbClr val="FFFFFF"/>
                 </a:solidFill>
@@ -8810,320 +8889,7 @@
                 <a:cs typeface="Roboto"/>
                 <a:sym typeface="Roboto"/>
               </a:rPr>
-              <a:t>Determinado a provar seu valor, você decide se inscrever na maior competição de Mandinhos™ do mundo, onde o perdedor é obrigado a passar a posse do Mandinho™ que batalhou ao vencedor.</a:t>
-            </a:r>
-          </a:p>
-          <a:p>
-            <a:pPr algn="just">
-              <a:lnSpc>
-                <a:spcPts val="2609"/>
-              </a:lnSpc>
-            </a:pPr>
-            <a:r>
-              <a:rPr lang="en-US" sz="1864">
-                <a:solidFill>
-                  <a:srgbClr val="FFFFFF"/>
-                </a:solidFill>
-                <a:latin typeface="Roboto"/>
-                <a:ea typeface="Roboto"/>
-                <a:cs typeface="Roboto"/>
-                <a:sym typeface="Roboto"/>
-              </a:rPr>
-              <a:t>Após avançar pelas etapas sem grandes dificuldades, você chega à final, onde enfrenta sua rival: uma veterana em batalhas e no treinamento de Mandinhos™, cujo objetivo é vencer todos os maiores torneios do mundo.</a:t>
-            </a:r>
-          </a:p>
-          <a:p>
-            <a:pPr algn="just">
-              <a:lnSpc>
-                <a:spcPts val="2609"/>
-              </a:lnSpc>
-            </a:pPr>
-            <a:r>
-              <a:rPr lang="en-US" sz="1864">
-                <a:solidFill>
-                  <a:srgbClr val="FFFFFF"/>
-                </a:solidFill>
-                <a:latin typeface="Roboto"/>
-                <a:ea typeface="Roboto"/>
-                <a:cs typeface="Roboto"/>
-                <a:sym typeface="Roboto"/>
-              </a:rPr>
-              <a:t>Depois de uma batalha árdua e intensa, você acaba derrotado.</a:t>
-            </a:r>
-          </a:p>
-          <a:p>
-            <a:pPr algn="just">
-              <a:lnSpc>
-                <a:spcPts val="2609"/>
-              </a:lnSpc>
-            </a:pPr>
-            <a:r>
-              <a:rPr lang="en-US" sz="1864">
-                <a:solidFill>
-                  <a:srgbClr val="FFFFFF"/>
-                </a:solidFill>
-                <a:latin typeface="Roboto"/>
-                <a:ea typeface="Roboto"/>
-                <a:cs typeface="Roboto"/>
-                <a:sym typeface="Roboto"/>
-              </a:rPr>
-              <a:t>Como consequência, você perde seu melhor amigo e companheiro, {mandinho}.</a:t>
-            </a:r>
-          </a:p>
-          <a:p>
-            <a:pPr algn="just">
-              <a:lnSpc>
-                <a:spcPts val="2609"/>
-              </a:lnSpc>
-              <a:spcBef>
-                <a:spcPct val="0"/>
-              </a:spcBef>
-            </a:pPr>
-          </a:p>
-        </p:txBody>
-      </p:sp>
-      <p:sp>
-        <p:nvSpPr>
-          <p:cNvPr name="Freeform 23" id="23"/>
-          <p:cNvSpPr/>
-          <p:nvPr/>
-        </p:nvSpPr>
-        <p:spPr>
-          <a:xfrm flipH="true" flipV="false" rot="0">
-            <a:off x="4671596" y="438644"/>
-            <a:ext cx="608122" cy="608122"/>
-          </a:xfrm>
-          <a:custGeom>
-            <a:avLst/>
-            <a:gdLst/>
-            <a:ahLst/>
-            <a:cxnLst/>
-            <a:rect r="r" b="b" t="t" l="l"/>
-            <a:pathLst>
-              <a:path h="608122" w="608122">
-                <a:moveTo>
-                  <a:pt x="608122" y="0"/>
-                </a:moveTo>
-                <a:lnTo>
-                  <a:pt x="0" y="0"/>
-                </a:lnTo>
-                <a:lnTo>
-                  <a:pt x="0" y="608122"/>
-                </a:lnTo>
-                <a:lnTo>
-                  <a:pt x="608122" y="608122"/>
-                </a:lnTo>
-                <a:lnTo>
-                  <a:pt x="608122" y="0"/>
-                </a:lnTo>
-                <a:close/>
-              </a:path>
-            </a:pathLst>
-          </a:custGeom>
-          <a:blipFill>
-            <a:blip r:embed="rId13">
-              <a:extLst>
-                <a:ext uri="{96DAC541-7B7A-43D3-8B79-37D633B846F1}">
-                  <asvg:svgBlip xmlns:asvg="http://schemas.microsoft.com/office/drawing/2016/SVG/main" r:embed="rId14"/>
-                </a:ext>
-              </a:extLst>
-            </a:blip>
-            <a:stretch>
-              <a:fillRect l="0" t="0" r="0" b="0"/>
-            </a:stretch>
-          </a:blipFill>
-        </p:spPr>
-      </p:sp>
-      <p:sp>
-        <p:nvSpPr>
-          <p:cNvPr name="Freeform 24" id="24"/>
-          <p:cNvSpPr/>
-          <p:nvPr/>
-        </p:nvSpPr>
-        <p:spPr>
-          <a:xfrm flipH="true" flipV="false" rot="0">
-            <a:off x="8394869" y="328008"/>
-            <a:ext cx="608122" cy="608122"/>
-          </a:xfrm>
-          <a:custGeom>
-            <a:avLst/>
-            <a:gdLst/>
-            <a:ahLst/>
-            <a:cxnLst/>
-            <a:rect r="r" b="b" t="t" l="l"/>
-            <a:pathLst>
-              <a:path h="608122" w="608122">
-                <a:moveTo>
-                  <a:pt x="608122" y="0"/>
-                </a:moveTo>
-                <a:lnTo>
-                  <a:pt x="0" y="0"/>
-                </a:lnTo>
-                <a:lnTo>
-                  <a:pt x="0" y="608122"/>
-                </a:lnTo>
-                <a:lnTo>
-                  <a:pt x="608122" y="608122"/>
-                </a:lnTo>
-                <a:lnTo>
-                  <a:pt x="608122" y="0"/>
-                </a:lnTo>
-                <a:close/>
-              </a:path>
-            </a:pathLst>
-          </a:custGeom>
-          <a:blipFill>
-            <a:blip r:embed="rId13">
-              <a:extLst>
-                <a:ext uri="{96DAC541-7B7A-43D3-8B79-37D633B846F1}">
-                  <asvg:svgBlip xmlns:asvg="http://schemas.microsoft.com/office/drawing/2016/SVG/main" r:embed="rId14"/>
-                </a:ext>
-              </a:extLst>
-            </a:blip>
-            <a:stretch>
-              <a:fillRect l="0" t="0" r="0" b="0"/>
-            </a:stretch>
-          </a:blipFill>
-        </p:spPr>
-      </p:sp>
-      <p:sp>
-        <p:nvSpPr>
-          <p:cNvPr name="Freeform 25" id="25"/>
-          <p:cNvSpPr/>
-          <p:nvPr/>
-        </p:nvSpPr>
-        <p:spPr>
-          <a:xfrm flipH="true" flipV="false" rot="0">
-            <a:off x="16126300" y="150840"/>
-            <a:ext cx="608122" cy="608122"/>
-          </a:xfrm>
-          <a:custGeom>
-            <a:avLst/>
-            <a:gdLst/>
-            <a:ahLst/>
-            <a:cxnLst/>
-            <a:rect r="r" b="b" t="t" l="l"/>
-            <a:pathLst>
-              <a:path h="608122" w="608122">
-                <a:moveTo>
-                  <a:pt x="608122" y="0"/>
-                </a:moveTo>
-                <a:lnTo>
-                  <a:pt x="0" y="0"/>
-                </a:lnTo>
-                <a:lnTo>
-                  <a:pt x="0" y="608122"/>
-                </a:lnTo>
-                <a:lnTo>
-                  <a:pt x="608122" y="608122"/>
-                </a:lnTo>
-                <a:lnTo>
-                  <a:pt x="608122" y="0"/>
-                </a:lnTo>
-                <a:close/>
-              </a:path>
-            </a:pathLst>
-          </a:custGeom>
-          <a:blipFill>
-            <a:blip r:embed="rId13">
-              <a:extLst>
-                <a:ext uri="{96DAC541-7B7A-43D3-8B79-37D633B846F1}">
-                  <asvg:svgBlip xmlns:asvg="http://schemas.microsoft.com/office/drawing/2016/SVG/main" r:embed="rId14"/>
-                </a:ext>
-              </a:extLst>
-            </a:blip>
-            <a:stretch>
-              <a:fillRect l="0" t="0" r="0" b="0"/>
-            </a:stretch>
-          </a:blipFill>
-        </p:spPr>
-      </p:sp>
-      <p:sp>
-        <p:nvSpPr>
-          <p:cNvPr name="Freeform 26" id="26"/>
-          <p:cNvSpPr/>
-          <p:nvPr/>
-        </p:nvSpPr>
-        <p:spPr>
-          <a:xfrm flipH="false" flipV="false" rot="0">
-            <a:off x="16166242" y="-425881"/>
-            <a:ext cx="3138073" cy="1765166"/>
-          </a:xfrm>
-          <a:custGeom>
-            <a:avLst/>
-            <a:gdLst/>
-            <a:ahLst/>
-            <a:cxnLst/>
-            <a:rect r="r" b="b" t="t" l="l"/>
-            <a:pathLst>
-              <a:path h="1765166" w="3138073">
-                <a:moveTo>
-                  <a:pt x="0" y="0"/>
-                </a:moveTo>
-                <a:lnTo>
-                  <a:pt x="3138073" y="0"/>
-                </a:lnTo>
-                <a:lnTo>
-                  <a:pt x="3138073" y="1765166"/>
-                </a:lnTo>
-                <a:lnTo>
-                  <a:pt x="0" y="1765166"/>
-                </a:lnTo>
-                <a:lnTo>
-                  <a:pt x="0" y="0"/>
-                </a:lnTo>
-                <a:close/>
-              </a:path>
-            </a:pathLst>
-          </a:custGeom>
-          <a:blipFill>
-            <a:blip r:embed="rId15"/>
-            <a:stretch>
-              <a:fillRect l="0" t="0" r="0" b="0"/>
-            </a:stretch>
-          </a:blipFill>
-        </p:spPr>
-      </p:sp>
-      <p:sp>
-        <p:nvSpPr>
-          <p:cNvPr name="TextBox 27" id="27"/>
-          <p:cNvSpPr txBox="true"/>
-          <p:nvPr/>
-        </p:nvSpPr>
-        <p:spPr>
-          <a:xfrm rot="0">
-            <a:off x="1326867" y="3213198"/>
-            <a:ext cx="6689457" cy="325806"/>
-          </a:xfrm>
-          <a:prstGeom prst="rect">
-            <a:avLst/>
-          </a:prstGeom>
-        </p:spPr>
-        <p:txBody>
-          <a:bodyPr anchor="t" rtlCol="false" tIns="0" lIns="0" bIns="0" rIns="0">
-            <a:spAutoFit/>
-          </a:bodyPr>
-          <a:lstStyle/>
-          <a:p>
-            <a:pPr algn="just">
-              <a:lnSpc>
-                <a:spcPts val="2609"/>
-              </a:lnSpc>
-              <a:spcBef>
-                <a:spcPct val="0"/>
-              </a:spcBef>
-            </a:pPr>
-            <a:r>
-              <a:rPr lang="en-US" sz="1864">
-                <a:solidFill>
-                  <a:srgbClr val="FFFFFF"/>
-                </a:solidFill>
-                <a:latin typeface="Roboto"/>
-                <a:ea typeface="Roboto"/>
-                <a:cs typeface="Roboto"/>
-                <a:sym typeface="Roboto"/>
-              </a:rPr>
-              <a:t>Ao perder seu </a:t>
+              <a:t>Para isso você deve começar sua jornada novamente, treinando, evoluindo e conquistando novos mandinhos.</a:t>
             </a:r>
           </a:p>
         </p:txBody>
@@ -9938,7 +9704,7 @@
         </p:nvSpPr>
         <p:spPr>
           <a:xfrm flipH="false" flipV="false" rot="0">
-            <a:off x="6937304" y="5959260"/>
+            <a:off x="7163753" y="5412883"/>
             <a:ext cx="3960495" cy="1984758"/>
           </a:xfrm>
           <a:custGeom>

</xml_diff>